<commit_message>
Generalized to all Assignment Groups
</commit_message>
<xml_diff>
--- a/docs/Aged_Ticket_Advisor_Detailed.pptx
+++ b/docs/Aged_Ticket_Advisor_Detailed.pptx
@@ -5736,7 +5736,7 @@
                 </a:solidFill>
                 <a:latin typeface="Segoe UI"/>
               </a:rPr>
-              <a:t>Time since the last real Service Desk action</a:t>
+              <a:t>Time since the last real action by the assigned team</a:t>
             </a:r>
           </a:p>
         </p:txBody>
@@ -12737,7 +12737,7 @@
                           </a:solidFill>
                           <a:latin typeface="Segoe UI"/>
                         </a:rPr>
-                        <a:t>No real Service Desk action past the threshold</a:t>
+                        <a:t>No real action by the assigned team past the threshold</a:t>
                       </a:r>
                     </a:p>
                   </a:txBody>
@@ -17537,7 +17537,7 @@
                           </a:solidFill>
                           <a:latin typeface="Segoe UI"/>
                         </a:rPr>
-                        <a:t>Service Desk leads</a:t>
+                        <a:t>Team leads</a:t>
                       </a:r>
                     </a:p>
                   </a:txBody>
@@ -18967,7 +18967,7 @@
                           </a:solidFill>
                           <a:latin typeface="Segoe UI"/>
                         </a:rPr>
-                        <a:t>Reassigned out of the Service Desk</a:t>
+                        <a:t>Reassigned to a queue we do not cover</a:t>
                       </a:r>
                     </a:p>
                   </a:txBody>
@@ -21201,7 +21201,7 @@
                 </a:solidFill>
                 <a:latin typeface="Segoe UI"/>
               </a:rPr>
-              <a:t>What we need from the Service Desk</a:t>
+              <a:t>What we need from the teams</a:t>
             </a:r>
           </a:p>
         </p:txBody>
@@ -22656,7 +22656,7 @@
                 </a:solidFill>
                 <a:latin typeface="Segoe UI"/>
               </a:rPr>
-              <a:t>A caller replying does not mean the Service Desk acted. It usually means the opposite.</a:t>
+              <a:t>A caller replying does not mean the assigned team acted. It usually means the opposite.</a:t>
             </a:r>
           </a:p>
           <a:p>
@@ -23207,7 +23207,7 @@
                           </a:solidFill>
                           <a:latin typeface="Segoe UI"/>
                         </a:rPr>
-                        <a:t>Service Desk</a:t>
+                        <a:t>Assigned team</a:t>
                       </a:r>
                     </a:p>
                   </a:txBody>

</xml_diff>